<commit_message>
Fix disrespectful slide label and irrelevant stat across all decks
- Rename the "The Prospect" eyebrow label to "Who You Are" on the
  profile slide in all four pitch decks -- the recipient reads this
  deck, so internal sales jargon about them has no place in it.
- Replace the "80+ loan officers nationwide" stat (Who We Are slide,
  plus the licensing-slide body copy on the Elefante/Morgan decks)
  with "Real hands on every file" / "real, licensed loan officers on
  every file" -- our own headcount is irrelevant to a partner; what
  matters to them is whether their referred students get real service.

Co-Authored-By: Claude Sonnet 5 <noreply@anthropic.com>
Claude-Session: https://claude.ai/code/session_01GSVmMzMB2kE2GrdJTA9Ems
</commit_message>
<xml_diff>
--- a/outreach/pitch-decks/cliffco-kenny-bedwell-partnership.pptx
+++ b/outreach/pitch-decks/cliffco-kenny-bedwell-partnership.pptx
@@ -3279,7 +3279,7 @@
                 <a:ea typeface="Arial" pitchFamily="34" charset="-122"/>
                 <a:cs typeface="Arial" pitchFamily="34" charset="-120"/>
               </a:rPr>
-              <a:t>80+ loan officers nationwide</a:t>
+              <a:t>Real hands on every file</a:t>
             </a:r>
             <a:endParaRPr lang="en-US" sz="1300" dirty="0"/>
           </a:p>
@@ -3712,7 +3712,7 @@
                 <a:ea typeface="Montserrat" pitchFamily="34" charset="-122"/>
                 <a:cs typeface="Montserrat" pitchFamily="34" charset="-120"/>
               </a:rPr>
-              <a:t>THE PROSPECT</a:t>
+              <a:t>WHO YOU ARE</a:t>
             </a:r>
             <a:endParaRPr lang="en-US" sz="1400" dirty="0"/>
           </a:p>

</xml_diff>